<commit_message>
refactor(academy): 마스코트 최소화(cat_cheer 1종만) + 카드 경계 강화
페이지:
- /academy hero: 단일 마스코트(cat_cheer), 다른 마스코트 모두 제거
- /academy/lv1 hero: 마스코트 제거 (텍스트 중심)
- 모든 카드 border-2 + 색상 강화 (foreground/15, primary)
- Lv1 강의 목차 카드도 동일 처리

자료:
- Lv1 PPTX/PDF 재생성 (cat_cheer만 슬라이드 1·11에 사용)
- 11장 슬라이드 중 9곳에서 마스코트 제거 → 2곳 유지
</commit_message>
<xml_diff>
--- a/public/academy/lv1-slides.pptx
+++ b/public/academy/lv1-slides.pptx
@@ -3361,7 +3361,7 @@
       </p:sp>
       <p:pic>
         <p:nvPicPr>
-          <p:cNvPr id="9" name="Picture 8" descr="cat_intro.png"/>
+          <p:cNvPr id="9" name="Picture 8" descr="cat_cheer.png"/>
           <p:cNvPicPr>
             <a:picLocks noChangeAspect="1"/>
           </p:cNvPicPr>
@@ -3376,7 +3376,7 @@
         <p:spPr>
           <a:xfrm>
             <a:off x="8595360" y="1280160"/>
-            <a:ext cx="2668191" cy="4114800"/>
+            <a:ext cx="4114800" cy="4114800"/>
           </a:xfrm>
           <a:prstGeom prst="rect">
             <a:avLst/>
@@ -4247,33 +4247,9 @@
           </a:p>
         </p:txBody>
       </p:sp>
-      <p:pic>
-        <p:nvPicPr>
-          <p:cNvPr id="22" name="Picture 21" descr="cat_support.png"/>
-          <p:cNvPicPr>
-            <a:picLocks noChangeAspect="1"/>
-          </p:cNvPicPr>
-          <p:nvPr/>
-        </p:nvPicPr>
-        <p:blipFill>
-          <a:blip r:embed="rId2"/>
-          <a:stretch>
-            <a:fillRect/>
-          </a:stretch>
-        </p:blipFill>
-        <p:spPr>
-          <a:xfrm>
-            <a:off x="4114800" y="640080"/>
-            <a:ext cx="1525905" cy="1097280"/>
-          </a:xfrm>
-          <a:prstGeom prst="rect">
-            <a:avLst/>
-          </a:prstGeom>
-        </p:spPr>
-      </p:pic>
-      <p:sp>
-        <p:nvSpPr>
-          <p:cNvPr id="23" name="TextBox 22"/>
+      <p:sp>
+        <p:nvSpPr>
+          <p:cNvPr id="22" name="TextBox 21"/>
           <p:cNvSpPr txBox="1"/>
           <p:nvPr/>
         </p:nvSpPr>
@@ -4308,7 +4284,7 @@
       </p:sp>
       <p:sp>
         <p:nvSpPr>
-          <p:cNvPr id="24" name="TextBox 23"/>
+          <p:cNvPr id="23" name="TextBox 22"/>
           <p:cNvSpPr txBox="1"/>
           <p:nvPr/>
         </p:nvSpPr>
@@ -5205,7 +5181,7 @@
       </p:sp>
       <p:pic>
         <p:nvPicPr>
-          <p:cNvPr id="24" name="Picture 23" descr="cat_thanks.png"/>
+          <p:cNvPr id="24" name="Picture 23" descr="cat_cheer.png"/>
           <p:cNvPicPr>
             <a:picLocks noChangeAspect="1"/>
           </p:cNvPicPr>
@@ -5220,7 +5196,7 @@
         <p:spPr>
           <a:xfrm>
             <a:off x="9509760" y="731520"/>
-            <a:ext cx="1143000" cy="1828800"/>
+            <a:ext cx="1828800" cy="1828800"/>
           </a:xfrm>
           <a:prstGeom prst="rect">
             <a:avLst/>
@@ -6020,33 +5996,9 @@
           </a:p>
         </p:txBody>
       </p:sp>
-      <p:pic>
-        <p:nvPicPr>
-          <p:cNvPr id="21" name="Picture 20" descr="cat_guide.png"/>
-          <p:cNvPicPr>
-            <a:picLocks noChangeAspect="1"/>
-          </p:cNvPicPr>
-          <p:nvPr/>
-        </p:nvPicPr>
-        <p:blipFill>
-          <a:blip r:embed="rId2"/>
-          <a:stretch>
-            <a:fillRect/>
-          </a:stretch>
-        </p:blipFill>
-        <p:spPr>
-          <a:xfrm>
-            <a:off x="10058400" y="914400"/>
-            <a:ext cx="1645920" cy="1645920"/>
-          </a:xfrm>
-          <a:prstGeom prst="rect">
-            <a:avLst/>
-          </a:prstGeom>
-        </p:spPr>
-      </p:pic>
-      <p:sp>
-        <p:nvSpPr>
-          <p:cNvPr id="22" name="TextBox 21"/>
+      <p:sp>
+        <p:nvSpPr>
+          <p:cNvPr id="21" name="TextBox 20"/>
           <p:cNvSpPr txBox="1"/>
           <p:nvPr/>
         </p:nvSpPr>
@@ -6081,7 +6033,7 @@
       </p:sp>
       <p:sp>
         <p:nvSpPr>
-          <p:cNvPr id="23" name="TextBox 22"/>
+          <p:cNvPr id="22" name="TextBox 21"/>
           <p:cNvSpPr txBox="1"/>
           <p:nvPr/>
         </p:nvSpPr>
@@ -6779,33 +6731,9 @@
           </a:p>
         </p:txBody>
       </p:sp>
-      <p:pic>
-        <p:nvPicPr>
-          <p:cNvPr id="19" name="Picture 18" descr="cat_main.png"/>
-          <p:cNvPicPr>
-            <a:picLocks noChangeAspect="1"/>
-          </p:cNvPicPr>
-          <p:nvPr/>
-        </p:nvPicPr>
-        <p:blipFill>
-          <a:blip r:embed="rId2"/>
-          <a:stretch>
-            <a:fillRect/>
-          </a:stretch>
-        </p:blipFill>
-        <p:spPr>
-          <a:xfrm>
-            <a:off x="9601200" y="1188720"/>
-            <a:ext cx="2194560" cy="2194560"/>
-          </a:xfrm>
-          <a:prstGeom prst="rect">
-            <a:avLst/>
-          </a:prstGeom>
-        </p:spPr>
-      </p:pic>
-      <p:sp>
-        <p:nvSpPr>
-          <p:cNvPr id="20" name="TextBox 19"/>
+      <p:sp>
+        <p:nvSpPr>
+          <p:cNvPr id="19" name="TextBox 18"/>
           <p:cNvSpPr txBox="1"/>
           <p:nvPr/>
         </p:nvSpPr>
@@ -6840,7 +6768,7 @@
       </p:sp>
       <p:sp>
         <p:nvSpPr>
-          <p:cNvPr id="21" name="TextBox 20"/>
+          <p:cNvPr id="20" name="TextBox 19"/>
           <p:cNvSpPr txBox="1"/>
           <p:nvPr/>
         </p:nvSpPr>
@@ -7620,33 +7548,9 @@
           </a:p>
         </p:txBody>
       </p:sp>
-      <p:pic>
-        <p:nvPicPr>
-          <p:cNvPr id="21" name="Picture 20" descr="cat_guide.png"/>
-          <p:cNvPicPr>
-            <a:picLocks noChangeAspect="1"/>
-          </p:cNvPicPr>
-          <p:nvPr/>
-        </p:nvPicPr>
-        <p:blipFill>
-          <a:blip r:embed="rId2"/>
-          <a:stretch>
-            <a:fillRect/>
-          </a:stretch>
-        </p:blipFill>
-        <p:spPr>
-          <a:xfrm>
-            <a:off x="9784080" y="914400"/>
-            <a:ext cx="1828800" cy="1828800"/>
-          </a:xfrm>
-          <a:prstGeom prst="rect">
-            <a:avLst/>
-          </a:prstGeom>
-        </p:spPr>
-      </p:pic>
-      <p:sp>
-        <p:nvSpPr>
-          <p:cNvPr id="22" name="TextBox 21"/>
+      <p:sp>
+        <p:nvSpPr>
+          <p:cNvPr id="21" name="TextBox 20"/>
           <p:cNvSpPr txBox="1"/>
           <p:nvPr/>
         </p:nvSpPr>
@@ -7681,7 +7585,7 @@
       </p:sp>
       <p:sp>
         <p:nvSpPr>
-          <p:cNvPr id="23" name="TextBox 22"/>
+          <p:cNvPr id="22" name="TextBox 21"/>
           <p:cNvSpPr txBox="1"/>
           <p:nvPr/>
         </p:nvSpPr>
@@ -10220,33 +10124,9 @@
           </a:p>
         </p:txBody>
       </p:sp>
-      <p:pic>
-        <p:nvPicPr>
-          <p:cNvPr id="29" name="Picture 28" descr="cat_vision.png"/>
-          <p:cNvPicPr>
-            <a:picLocks noChangeAspect="1"/>
-          </p:cNvPicPr>
-          <p:nvPr/>
-        </p:nvPicPr>
-        <p:blipFill>
-          <a:blip r:embed="rId2"/>
-          <a:stretch>
-            <a:fillRect/>
-          </a:stretch>
-        </p:blipFill>
-        <p:spPr>
-          <a:xfrm>
-            <a:off x="9601200" y="822960"/>
-            <a:ext cx="1645920" cy="1645920"/>
-          </a:xfrm>
-          <a:prstGeom prst="rect">
-            <a:avLst/>
-          </a:prstGeom>
-        </p:spPr>
-      </p:pic>
-      <p:sp>
-        <p:nvSpPr>
-          <p:cNvPr id="30" name="TextBox 29"/>
+      <p:sp>
+        <p:nvSpPr>
+          <p:cNvPr id="29" name="TextBox 28"/>
           <p:cNvSpPr txBox="1"/>
           <p:nvPr/>
         </p:nvSpPr>
@@ -10281,7 +10161,7 @@
       </p:sp>
       <p:sp>
         <p:nvSpPr>
-          <p:cNvPr id="31" name="TextBox 30"/>
+          <p:cNvPr id="30" name="TextBox 29"/>
           <p:cNvSpPr txBox="1"/>
           <p:nvPr/>
         </p:nvSpPr>
@@ -11108,33 +10988,9 @@
           </a:p>
         </p:txBody>
       </p:sp>
-      <p:pic>
-        <p:nvPicPr>
-          <p:cNvPr id="22" name="Picture 21" descr="cat_ui_like.png"/>
-          <p:cNvPicPr>
-            <a:picLocks noChangeAspect="1"/>
-          </p:cNvPicPr>
-          <p:nvPr/>
-        </p:nvPicPr>
-        <p:blipFill>
-          <a:blip r:embed="rId2"/>
-          <a:stretch>
-            <a:fillRect/>
-          </a:stretch>
-        </p:blipFill>
-        <p:spPr>
-          <a:xfrm>
-            <a:off x="4114800" y="640080"/>
-            <a:ext cx="771525" cy="1097280"/>
-          </a:xfrm>
-          <a:prstGeom prst="rect">
-            <a:avLst/>
-          </a:prstGeom>
-        </p:spPr>
-      </p:pic>
-      <p:sp>
-        <p:nvSpPr>
-          <p:cNvPr id="23" name="TextBox 22"/>
+      <p:sp>
+        <p:nvSpPr>
+          <p:cNvPr id="22" name="TextBox 21"/>
           <p:cNvSpPr txBox="1"/>
           <p:nvPr/>
         </p:nvSpPr>
@@ -11169,7 +11025,7 @@
       </p:sp>
       <p:sp>
         <p:nvSpPr>
-          <p:cNvPr id="24" name="TextBox 23"/>
+          <p:cNvPr id="23" name="TextBox 22"/>
           <p:cNvSpPr txBox="1"/>
           <p:nvPr/>
         </p:nvSpPr>
@@ -12156,33 +12012,9 @@
           </a:p>
         </p:txBody>
       </p:sp>
-      <p:pic>
-        <p:nvPicPr>
-          <p:cNvPr id="26" name="Picture 25" descr="cat_ui_check.png"/>
-          <p:cNvPicPr>
-            <a:picLocks noChangeAspect="1"/>
-          </p:cNvPicPr>
-          <p:nvPr/>
-        </p:nvPicPr>
-        <p:blipFill>
-          <a:blip r:embed="rId2"/>
-          <a:stretch>
-            <a:fillRect/>
-          </a:stretch>
-        </p:blipFill>
-        <p:spPr>
-          <a:xfrm>
-            <a:off x="4114800" y="640080"/>
-            <a:ext cx="840105" cy="1097280"/>
-          </a:xfrm>
-          <a:prstGeom prst="rect">
-            <a:avLst/>
-          </a:prstGeom>
-        </p:spPr>
-      </p:pic>
-      <p:sp>
-        <p:nvSpPr>
-          <p:cNvPr id="27" name="TextBox 26"/>
+      <p:sp>
+        <p:nvSpPr>
+          <p:cNvPr id="26" name="TextBox 25"/>
           <p:cNvSpPr txBox="1"/>
           <p:nvPr/>
         </p:nvSpPr>
@@ -12217,7 +12049,7 @@
       </p:sp>
       <p:sp>
         <p:nvSpPr>
-          <p:cNvPr id="28" name="TextBox 27"/>
+          <p:cNvPr id="27" name="TextBox 26"/>
           <p:cNvSpPr txBox="1"/>
           <p:nvPr/>
         </p:nvSpPr>
@@ -13044,33 +12876,9 @@
           </a:p>
         </p:txBody>
       </p:sp>
-      <p:pic>
-        <p:nvPicPr>
-          <p:cNvPr id="22" name="Picture 21" descr="cat_notice.png"/>
-          <p:cNvPicPr>
-            <a:picLocks noChangeAspect="1"/>
-          </p:cNvPicPr>
-          <p:nvPr/>
-        </p:nvPicPr>
-        <p:blipFill>
-          <a:blip r:embed="rId2"/>
-          <a:stretch>
-            <a:fillRect/>
-          </a:stretch>
-        </p:blipFill>
-        <p:spPr>
-          <a:xfrm>
-            <a:off x="4114800" y="640080"/>
-            <a:ext cx="960120" cy="1097280"/>
-          </a:xfrm>
-          <a:prstGeom prst="rect">
-            <a:avLst/>
-          </a:prstGeom>
-        </p:spPr>
-      </p:pic>
-      <p:sp>
-        <p:nvSpPr>
-          <p:cNvPr id="23" name="TextBox 22"/>
+      <p:sp>
+        <p:nvSpPr>
+          <p:cNvPr id="22" name="TextBox 21"/>
           <p:cNvSpPr txBox="1"/>
           <p:nvPr/>
         </p:nvSpPr>
@@ -13105,7 +12913,7 @@
       </p:sp>
       <p:sp>
         <p:nvSpPr>
-          <p:cNvPr id="24" name="TextBox 23"/>
+          <p:cNvPr id="23" name="TextBox 22"/>
           <p:cNvSpPr txBox="1"/>
           <p:nvPr/>
         </p:nvSpPr>

</xml_diff>